<commit_message>
docs: remove redaction notices from attention copies
</commit_message>
<xml_diff>
--- a/attention融合算子优化报告/attention融合算子优化报告_脱敏版.pptx
+++ b/attention融合算子优化报告/attention融合算子优化报告_脱敏版.pptx
@@ -2,36 +2,36 @@
 <file path=ppt/presentation.xml><?xml version="1.0" encoding="utf-8"?>
 <p:presentation xmlns:p="http://schemas.openxmlformats.org/presentationml/2006/main">
   <p:sldMasterIdLst>
-    <p:sldMasterId xmlns:r="http://schemas.openxmlformats.org/officeDocument/2006/relationships" id="2147483648" r:id="R5dedaf3a9d7d4f39"/>
+    <p:sldMasterId xmlns:r="http://schemas.openxmlformats.org/officeDocument/2006/relationships" id="2147483648" r:id="Rbd62b0e4eee7428b"/>
   </p:sldMasterIdLst>
   <p:notesMasterIdLst>
-    <p:notesMasterId xmlns:r="http://schemas.openxmlformats.org/officeDocument/2006/relationships" r:id="Rfbf1f2ca6b264b4a"/>
+    <p:notesMasterId xmlns:r="http://schemas.openxmlformats.org/officeDocument/2006/relationships" r:id="R878abc368f1d455e"/>
   </p:notesMasterIdLst>
   <p:sldIdLst>
-    <p:sldId xmlns:r="http://schemas.openxmlformats.org/officeDocument/2006/relationships" id="256" r:id="R75a832f67338424c"/>
-    <p:sldId xmlns:r="http://schemas.openxmlformats.org/officeDocument/2006/relationships" id="257" r:id="R313915d025a54419"/>
-    <p:sldId xmlns:r="http://schemas.openxmlformats.org/officeDocument/2006/relationships" id="258" r:id="R97ba2694e5fd4d8d"/>
-    <p:sldId xmlns:r="http://schemas.openxmlformats.org/officeDocument/2006/relationships" id="259" r:id="R48758205e14d43b2"/>
-    <p:sldId xmlns:r="http://schemas.openxmlformats.org/officeDocument/2006/relationships" id="260" r:id="R303b4b1ff5d44ce8"/>
-    <p:sldId xmlns:r="http://schemas.openxmlformats.org/officeDocument/2006/relationships" id="261" r:id="R1c57cc36635d4cc8"/>
-    <p:sldId xmlns:r="http://schemas.openxmlformats.org/officeDocument/2006/relationships" id="262" r:id="R40914abcf4984487"/>
-    <p:sldId xmlns:r="http://schemas.openxmlformats.org/officeDocument/2006/relationships" id="263" r:id="R56a5ac549f4f49d9"/>
-    <p:sldId xmlns:r="http://schemas.openxmlformats.org/officeDocument/2006/relationships" id="264" r:id="R7b54250e9e844178"/>
-    <p:sldId xmlns:r="http://schemas.openxmlformats.org/officeDocument/2006/relationships" id="265" r:id="Rcea2b796acbd4a4a"/>
-    <p:sldId xmlns:r="http://schemas.openxmlformats.org/officeDocument/2006/relationships" id="266" r:id="Re0b36beb9a184011"/>
-    <p:sldId xmlns:r="http://schemas.openxmlformats.org/officeDocument/2006/relationships" id="267" r:id="Rf53ab1f9ca794054"/>
-    <p:sldId xmlns:r="http://schemas.openxmlformats.org/officeDocument/2006/relationships" id="268" r:id="R1ff887fbe02b4a6b"/>
-    <p:sldId xmlns:r="http://schemas.openxmlformats.org/officeDocument/2006/relationships" id="269" r:id="Ra41bf54af65d4d65"/>
-    <p:sldId xmlns:r="http://schemas.openxmlformats.org/officeDocument/2006/relationships" id="270" r:id="Rd31685e830bb49cd"/>
-    <p:sldId xmlns:r="http://schemas.openxmlformats.org/officeDocument/2006/relationships" id="271" r:id="Rf6829f4736b54e12"/>
-    <p:sldId xmlns:r="http://schemas.openxmlformats.org/officeDocument/2006/relationships" id="272" r:id="Rbf30cbd8de59411c"/>
-    <p:sldId xmlns:r="http://schemas.openxmlformats.org/officeDocument/2006/relationships" id="273" r:id="R492d43e836cc487a"/>
-    <p:sldId xmlns:r="http://schemas.openxmlformats.org/officeDocument/2006/relationships" id="274" r:id="Rb3564e12efcc400f"/>
-    <p:sldId xmlns:r="http://schemas.openxmlformats.org/officeDocument/2006/relationships" id="275" r:id="Rf1be4ff803dc41a0"/>
-    <p:sldId xmlns:r="http://schemas.openxmlformats.org/officeDocument/2006/relationships" id="276" r:id="R38e0b489e8b946ad"/>
-    <p:sldId xmlns:r="http://schemas.openxmlformats.org/officeDocument/2006/relationships" id="277" r:id="Rd9e1ee4a1fc846a9"/>
-    <p:sldId xmlns:r="http://schemas.openxmlformats.org/officeDocument/2006/relationships" id="278" r:id="R584de50ab26a4c29"/>
-    <p:sldId xmlns:r="http://schemas.openxmlformats.org/officeDocument/2006/relationships" id="279" r:id="Rc44abe08bb7e46f1"/>
+    <p:sldId xmlns:r="http://schemas.openxmlformats.org/officeDocument/2006/relationships" id="256" r:id="R941e82ddac854242"/>
+    <p:sldId xmlns:r="http://schemas.openxmlformats.org/officeDocument/2006/relationships" id="257" r:id="R01e4b8ce2f344794"/>
+    <p:sldId xmlns:r="http://schemas.openxmlformats.org/officeDocument/2006/relationships" id="258" r:id="R7fd64fe33d4c42b5"/>
+    <p:sldId xmlns:r="http://schemas.openxmlformats.org/officeDocument/2006/relationships" id="259" r:id="R81873e82bf2646b6"/>
+    <p:sldId xmlns:r="http://schemas.openxmlformats.org/officeDocument/2006/relationships" id="260" r:id="R36487a361fc248c4"/>
+    <p:sldId xmlns:r="http://schemas.openxmlformats.org/officeDocument/2006/relationships" id="261" r:id="R8d9a17d1ee574170"/>
+    <p:sldId xmlns:r="http://schemas.openxmlformats.org/officeDocument/2006/relationships" id="262" r:id="R930c29792a8e41b0"/>
+    <p:sldId xmlns:r="http://schemas.openxmlformats.org/officeDocument/2006/relationships" id="263" r:id="R8134bc5dd6044d86"/>
+    <p:sldId xmlns:r="http://schemas.openxmlformats.org/officeDocument/2006/relationships" id="264" r:id="R27dbce3471814ee4"/>
+    <p:sldId xmlns:r="http://schemas.openxmlformats.org/officeDocument/2006/relationships" id="265" r:id="R931f4c26a9174f17"/>
+    <p:sldId xmlns:r="http://schemas.openxmlformats.org/officeDocument/2006/relationships" id="266" r:id="Rc1ce96686f1e4b8f"/>
+    <p:sldId xmlns:r="http://schemas.openxmlformats.org/officeDocument/2006/relationships" id="267" r:id="R00db0a753bc34fdf"/>
+    <p:sldId xmlns:r="http://schemas.openxmlformats.org/officeDocument/2006/relationships" id="268" r:id="R9faa3128524241de"/>
+    <p:sldId xmlns:r="http://schemas.openxmlformats.org/officeDocument/2006/relationships" id="269" r:id="R43691faed07b4b3a"/>
+    <p:sldId xmlns:r="http://schemas.openxmlformats.org/officeDocument/2006/relationships" id="270" r:id="Rf35683960a754782"/>
+    <p:sldId xmlns:r="http://schemas.openxmlformats.org/officeDocument/2006/relationships" id="271" r:id="Rd7d2a580459d42f8"/>
+    <p:sldId xmlns:r="http://schemas.openxmlformats.org/officeDocument/2006/relationships" id="272" r:id="Rac2a30311e0e4263"/>
+    <p:sldId xmlns:r="http://schemas.openxmlformats.org/officeDocument/2006/relationships" id="273" r:id="R28aa77c63b8f4a5d"/>
+    <p:sldId xmlns:r="http://schemas.openxmlformats.org/officeDocument/2006/relationships" id="274" r:id="Rd40ce71922f6454d"/>
+    <p:sldId xmlns:r="http://schemas.openxmlformats.org/officeDocument/2006/relationships" id="275" r:id="R469508aedaa643ab"/>
+    <p:sldId xmlns:r="http://schemas.openxmlformats.org/officeDocument/2006/relationships" id="276" r:id="R5798a0929cd04013"/>
+    <p:sldId xmlns:r="http://schemas.openxmlformats.org/officeDocument/2006/relationships" id="277" r:id="Rc85e03bfdd00470c"/>
+    <p:sldId xmlns:r="http://schemas.openxmlformats.org/officeDocument/2006/relationships" id="278" r:id="Rac29b343c34e46ad"/>
+    <p:sldId xmlns:r="http://schemas.openxmlformats.org/officeDocument/2006/relationships" id="279" r:id="R70d35bb19a694e06"/>
   </p:sldIdLst>
   <p:sldSz cx="12192000" cy="6858000"/>
   <p:notesSz cx="6858000" cy="9144000"/>
@@ -477,7 +477,7 @@
               <a:buNone/>
             </a:pPr>
             <a:r>
-              <a:t>讲解要点：交代对象：某视觉模型 视觉编码器中的二维相对位置偏置 Attention。报告按问题、改动、实测结果展开。</a:t>
+              <a:t>讲解要点：交代对象：视觉编码器中的二维相对位置偏置 Attention。报告按问题、改动、实测结果展开。</a:t>
             </a:r>
             <a:endParaRPr/>
           </a:p>
@@ -487,15 +487,6 @@
             </a:pPr>
             <a:r>
               <a:t>资料：attention融合算子优化_脱敏版.md §1</a:t>
-            </a:r>
-            <a:endParaRPr/>
-          </a:p>
-          <a:p xmlns:a="http://schemas.openxmlformats.org/drawingml/2006/main">
-            <a:pPr>
-              <a:buNone/>
-            </a:pPr>
-            <a:r>
-              <a:t>脱敏说明：算子以算子 A 代称，项目与设备标识已泛化；机制示意代码及性能数据保留。</a:t>
             </a:r>
             <a:endParaRPr/>
           </a:p>
@@ -2680,7 +2671,7 @@
   </p:cSld>
   <p:clrMap bg1="lt1" tx1="dk1" bg2="lt2" tx2="dk2" accent1="accent1" accent2="accent2" accent3="accent3" accent4="accent4" accent5="accent5" accent6="accent6" hlink="hlink" folHlink="folHlink"/>
   <p:sldLayoutIdLst>
-    <p:sldLayoutId xmlns:r="http://schemas.openxmlformats.org/officeDocument/2006/relationships" id="2147483649" r:id="Raeb90d4ef93b46b6"/>
+    <p:sldLayoutId xmlns:r="http://schemas.openxmlformats.org/officeDocument/2006/relationships" id="2147483649" r:id="Ra9acfa99b5da44b9"/>
   </p:sldLayoutIdLst>
   <p:txStyles>
     <p:titleStyle>
@@ -3235,7 +3226,7 @@
           <p:nvPr/>
         </p:nvPicPr>
         <p:blipFill>
-          <a:blip xmlns:r="http://schemas.openxmlformats.org/officeDocument/2006/relationships" xmlns:a="http://schemas.openxmlformats.org/drawingml/2006/main" r:embed="R66d36660dac24c3d"/>
+          <a:blip xmlns:r="http://schemas.openxmlformats.org/officeDocument/2006/relationships" xmlns:a="http://schemas.openxmlformats.org/drawingml/2006/main" r:embed="Rdd2be094ed3c4aae"/>
           <a:stretch xmlns:a="http://schemas.openxmlformats.org/drawingml/2006/main"/>
         </p:blipFill>
         <p:spPr>
@@ -3390,7 +3381,7 @@
                 <a:ea typeface="Microsoft YaHei"/>
                 <a:cs typeface="Microsoft YaHei"/>
               </a:rPr>
-              <a:t>算子 A 的数据流、流水与调度实践（脱敏版）</a:t>
+              <a:t>Attention 的数据流、流水与调度实践</a:t>
             </a:r>
             <a:endParaRPr/>
           </a:p>
@@ -3684,7 +3675,7 @@
           <p:nvPr/>
         </p:nvPicPr>
         <p:blipFill>
-          <a:blip xmlns:r="http://schemas.openxmlformats.org/officeDocument/2006/relationships" xmlns:a="http://schemas.openxmlformats.org/drawingml/2006/main" r:embed="R2334510faeb144d5"/>
+          <a:blip xmlns:r="http://schemas.openxmlformats.org/officeDocument/2006/relationships" xmlns:a="http://schemas.openxmlformats.org/drawingml/2006/main" r:embed="R8cb8d09baf2543af"/>
           <a:stretch xmlns:a="http://schemas.openxmlformats.org/drawingml/2006/main"/>
         </p:blipFill>
         <p:spPr>
@@ -5004,7 +4995,7 @@
           <p:nvPr/>
         </p:nvPicPr>
         <p:blipFill>
-          <a:blip xmlns:r="http://schemas.openxmlformats.org/officeDocument/2006/relationships" xmlns:a="http://schemas.openxmlformats.org/drawingml/2006/main" r:embed="R896d299db5464690"/>
+          <a:blip xmlns:r="http://schemas.openxmlformats.org/officeDocument/2006/relationships" xmlns:a="http://schemas.openxmlformats.org/drawingml/2006/main" r:embed="R1f4b46285d464b29"/>
           <a:stretch xmlns:a="http://schemas.openxmlformats.org/drawingml/2006/main"/>
         </p:blipFill>
         <p:spPr>
@@ -6082,7 +6073,7 @@
           <p:nvPr/>
         </p:nvPicPr>
         <p:blipFill>
-          <a:blip xmlns:r="http://schemas.openxmlformats.org/officeDocument/2006/relationships" xmlns:a="http://schemas.openxmlformats.org/drawingml/2006/main" r:embed="Rf469d6b1861e401e"/>
+          <a:blip xmlns:r="http://schemas.openxmlformats.org/officeDocument/2006/relationships" xmlns:a="http://schemas.openxmlformats.org/drawingml/2006/main" r:embed="R426a5301eb8b4853"/>
           <a:stretch xmlns:a="http://schemas.openxmlformats.org/drawingml/2006/main"/>
         </p:blipFill>
         <p:spPr>
@@ -7041,7 +7032,7 @@
           <p:nvPr/>
         </p:nvPicPr>
         <p:blipFill>
-          <a:blip xmlns:r="http://schemas.openxmlformats.org/officeDocument/2006/relationships" xmlns:a="http://schemas.openxmlformats.org/drawingml/2006/main" r:embed="R219bbe098d1e4da6"/>
+          <a:blip xmlns:r="http://schemas.openxmlformats.org/officeDocument/2006/relationships" xmlns:a="http://schemas.openxmlformats.org/drawingml/2006/main" r:embed="R99df8aee27b54bd4"/>
           <a:stretch xmlns:a="http://schemas.openxmlformats.org/drawingml/2006/main"/>
         </p:blipFill>
         <p:spPr>
@@ -7978,7 +7969,7 @@
           <p:nvPr/>
         </p:nvPicPr>
         <p:blipFill>
-          <a:blip xmlns:r="http://schemas.openxmlformats.org/officeDocument/2006/relationships" xmlns:a="http://schemas.openxmlformats.org/drawingml/2006/main" r:embed="Rd27fefd341e348d4"/>
+          <a:blip xmlns:r="http://schemas.openxmlformats.org/officeDocument/2006/relationships" xmlns:a="http://schemas.openxmlformats.org/drawingml/2006/main" r:embed="R9381c78ba0e947fc"/>
           <a:stretch xmlns:a="http://schemas.openxmlformats.org/drawingml/2006/main"/>
         </p:blipFill>
         <p:spPr>
@@ -9084,7 +9075,7 @@
           <p:nvPr/>
         </p:nvPicPr>
         <p:blipFill>
-          <a:blip xmlns:r="http://schemas.openxmlformats.org/officeDocument/2006/relationships" xmlns:a="http://schemas.openxmlformats.org/drawingml/2006/main" r:embed="R2d50b06d3e2f4d3c"/>
+          <a:blip xmlns:r="http://schemas.openxmlformats.org/officeDocument/2006/relationships" xmlns:a="http://schemas.openxmlformats.org/drawingml/2006/main" r:embed="R9d4eae07410e494c"/>
           <a:stretch xmlns:a="http://schemas.openxmlformats.org/drawingml/2006/main"/>
         </p:blipFill>
         <p:spPr>
@@ -10129,7 +10120,7 @@
           <p:nvPr/>
         </p:nvPicPr>
         <p:blipFill>
-          <a:blip xmlns:r="http://schemas.openxmlformats.org/officeDocument/2006/relationships" xmlns:a="http://schemas.openxmlformats.org/drawingml/2006/main" r:embed="R31ce9ab48d414db6"/>
+          <a:blip xmlns:r="http://schemas.openxmlformats.org/officeDocument/2006/relationships" xmlns:a="http://schemas.openxmlformats.org/drawingml/2006/main" r:embed="R5aa47786736c4120"/>
           <a:stretch xmlns:a="http://schemas.openxmlformats.org/drawingml/2006/main"/>
         </p:blipFill>
         <p:spPr>
@@ -11306,7 +11297,7 @@
           <p:nvPr/>
         </p:nvPicPr>
         <p:blipFill>
-          <a:blip xmlns:r="http://schemas.openxmlformats.org/officeDocument/2006/relationships" xmlns:a="http://schemas.openxmlformats.org/drawingml/2006/main" r:embed="R92be009d276d480e"/>
+          <a:blip xmlns:r="http://schemas.openxmlformats.org/officeDocument/2006/relationships" xmlns:a="http://schemas.openxmlformats.org/drawingml/2006/main" r:embed="R7e00c6097eb7468e"/>
           <a:stretch xmlns:a="http://schemas.openxmlformats.org/drawingml/2006/main"/>
         </p:blipFill>
         <p:spPr>
@@ -11328,7 +11319,7 @@
           <p:nvPr/>
         </p:nvPicPr>
         <p:blipFill>
-          <a:blip xmlns:r="http://schemas.openxmlformats.org/officeDocument/2006/relationships" xmlns:a="http://schemas.openxmlformats.org/drawingml/2006/main" r:embed="Rfd40010cba324509"/>
+          <a:blip xmlns:r="http://schemas.openxmlformats.org/officeDocument/2006/relationships" xmlns:a="http://schemas.openxmlformats.org/drawingml/2006/main" r:embed="R3e3fa6fa25c94d50"/>
           <a:stretch xmlns:a="http://schemas.openxmlformats.org/drawingml/2006/main"/>
         </p:blipFill>
         <p:spPr>
@@ -11350,7 +11341,7 @@
           <p:nvPr/>
         </p:nvPicPr>
         <p:blipFill>
-          <a:blip xmlns:r="http://schemas.openxmlformats.org/officeDocument/2006/relationships" xmlns:a="http://schemas.openxmlformats.org/drawingml/2006/main" r:embed="R90bd89d397564f43"/>
+          <a:blip xmlns:r="http://schemas.openxmlformats.org/officeDocument/2006/relationships" xmlns:a="http://schemas.openxmlformats.org/drawingml/2006/main" r:embed="Rd5a03c0c6c4445ae"/>
           <a:stretch xmlns:a="http://schemas.openxmlformats.org/drawingml/2006/main"/>
         </p:blipFill>
         <p:spPr>
@@ -11868,7 +11859,7 @@
           <p:nvPr/>
         </p:nvPicPr>
         <p:blipFill>
-          <a:blip xmlns:r="http://schemas.openxmlformats.org/officeDocument/2006/relationships" xmlns:a="http://schemas.openxmlformats.org/drawingml/2006/main" r:embed="Ra6440476ac4242a1"/>
+          <a:blip xmlns:r="http://schemas.openxmlformats.org/officeDocument/2006/relationships" xmlns:a="http://schemas.openxmlformats.org/drawingml/2006/main" r:embed="Rdac55ab392594007"/>
           <a:stretch xmlns:a="http://schemas.openxmlformats.org/drawingml/2006/main"/>
         </p:blipFill>
         <p:spPr>
@@ -13390,7 +13381,7 @@
           <p:nvPr/>
         </p:nvPicPr>
         <p:blipFill>
-          <a:blip xmlns:r="http://schemas.openxmlformats.org/officeDocument/2006/relationships" xmlns:a="http://schemas.openxmlformats.org/drawingml/2006/main" r:embed="R3eb373062fe44c18"/>
+          <a:blip xmlns:r="http://schemas.openxmlformats.org/officeDocument/2006/relationships" xmlns:a="http://schemas.openxmlformats.org/drawingml/2006/main" r:embed="R7d6a92a65c204116"/>
           <a:stretch xmlns:a="http://schemas.openxmlformats.org/drawingml/2006/main"/>
         </p:blipFill>
         <p:spPr>
@@ -15073,7 +15064,7 @@
           <p:nvPr/>
         </p:nvPicPr>
         <p:blipFill>
-          <a:blip xmlns:r="http://schemas.openxmlformats.org/officeDocument/2006/relationships" xmlns:a="http://schemas.openxmlformats.org/drawingml/2006/main" r:embed="R56ddc37eaf3c4c8b"/>
+          <a:blip xmlns:r="http://schemas.openxmlformats.org/officeDocument/2006/relationships" xmlns:a="http://schemas.openxmlformats.org/drawingml/2006/main" r:embed="Rf377c0d8116f46a2"/>
           <a:stretch xmlns:a="http://schemas.openxmlformats.org/drawingml/2006/main"/>
         </p:blipFill>
         <p:spPr>
@@ -15374,7 +15365,7 @@
           <p:nvPr/>
         </p:nvPicPr>
         <p:blipFill>
-          <a:blip xmlns:r="http://schemas.openxmlformats.org/officeDocument/2006/relationships" xmlns:a="http://schemas.openxmlformats.org/drawingml/2006/main" r:embed="Rc827654ba527494a"/>
+          <a:blip xmlns:r="http://schemas.openxmlformats.org/officeDocument/2006/relationships" xmlns:a="http://schemas.openxmlformats.org/drawingml/2006/main" r:embed="R859ef751483546b6"/>
           <a:stretch xmlns:a="http://schemas.openxmlformats.org/drawingml/2006/main"/>
         </p:blipFill>
         <p:spPr>
@@ -15396,7 +15387,7 @@
           <p:nvPr/>
         </p:nvPicPr>
         <p:blipFill>
-          <a:blip xmlns:r="http://schemas.openxmlformats.org/officeDocument/2006/relationships" xmlns:a="http://schemas.openxmlformats.org/drawingml/2006/main" r:embed="R551555ff10b44916"/>
+          <a:blip xmlns:r="http://schemas.openxmlformats.org/officeDocument/2006/relationships" xmlns:a="http://schemas.openxmlformats.org/drawingml/2006/main" r:embed="R01b22056015749fa"/>
           <a:stretch xmlns:a="http://schemas.openxmlformats.org/drawingml/2006/main"/>
         </p:blipFill>
         <p:spPr>
@@ -16910,7 +16901,7 @@
           <p:nvPr/>
         </p:nvPicPr>
         <p:blipFill>
-          <a:blip xmlns:r="http://schemas.openxmlformats.org/officeDocument/2006/relationships" xmlns:a="http://schemas.openxmlformats.org/drawingml/2006/main" r:embed="R6f9b588ec1004e61"/>
+          <a:blip xmlns:r="http://schemas.openxmlformats.org/officeDocument/2006/relationships" xmlns:a="http://schemas.openxmlformats.org/drawingml/2006/main" r:embed="R02b1fcf893f94af1"/>
           <a:stretch xmlns:a="http://schemas.openxmlformats.org/drawingml/2006/main"/>
         </p:blipFill>
         <p:spPr>
@@ -17211,7 +17202,7 @@
           <p:nvPr/>
         </p:nvPicPr>
         <p:blipFill>
-          <a:blip xmlns:r="http://schemas.openxmlformats.org/officeDocument/2006/relationships" xmlns:a="http://schemas.openxmlformats.org/drawingml/2006/main" r:embed="R55dccf5fe53142c7"/>
+          <a:blip xmlns:r="http://schemas.openxmlformats.org/officeDocument/2006/relationships" xmlns:a="http://schemas.openxmlformats.org/drawingml/2006/main" r:embed="Re8e9cf580bcd42c4"/>
           <a:stretch xmlns:a="http://schemas.openxmlformats.org/drawingml/2006/main"/>
         </p:blipFill>
         <p:spPr>
@@ -18111,7 +18102,7 @@
           <p:nvPr/>
         </p:nvPicPr>
         <p:blipFill>
-          <a:blip xmlns:r="http://schemas.openxmlformats.org/officeDocument/2006/relationships" xmlns:a="http://schemas.openxmlformats.org/drawingml/2006/main" r:embed="Rb674ff91e3d74e60"/>
+          <a:blip xmlns:r="http://schemas.openxmlformats.org/officeDocument/2006/relationships" xmlns:a="http://schemas.openxmlformats.org/drawingml/2006/main" r:embed="R4cdb1f864f6f42ad"/>
           <a:stretch xmlns:a="http://schemas.openxmlformats.org/drawingml/2006/main"/>
         </p:blipFill>
         <p:spPr>
@@ -19082,7 +19073,7 @@
           <p:nvPr/>
         </p:nvPicPr>
         <p:blipFill>
-          <a:blip xmlns:r="http://schemas.openxmlformats.org/officeDocument/2006/relationships" xmlns:a="http://schemas.openxmlformats.org/drawingml/2006/main" r:embed="R7abee7f444b84d6f"/>
+          <a:blip xmlns:r="http://schemas.openxmlformats.org/officeDocument/2006/relationships" xmlns:a="http://schemas.openxmlformats.org/drawingml/2006/main" r:embed="R7942ef92785a4d26"/>
           <a:stretch xmlns:a="http://schemas.openxmlformats.org/drawingml/2006/main"/>
         </p:blipFill>
         <p:spPr>
@@ -19383,7 +19374,7 @@
           <p:nvPr/>
         </p:nvPicPr>
         <p:blipFill>
-          <a:blip xmlns:r="http://schemas.openxmlformats.org/officeDocument/2006/relationships" xmlns:a="http://schemas.openxmlformats.org/drawingml/2006/main" r:embed="R07330994729e465a"/>
+          <a:blip xmlns:r="http://schemas.openxmlformats.org/officeDocument/2006/relationships" xmlns:a="http://schemas.openxmlformats.org/drawingml/2006/main" r:embed="R46ddd0b5564a4ac7"/>
           <a:stretch xmlns:a="http://schemas.openxmlformats.org/drawingml/2006/main"/>
         </p:blipFill>
         <p:spPr>
@@ -19518,7 +19509,7 @@
                           <a:ea typeface="Microsoft YaHei"/>
                           <a:cs typeface="Microsoft YaHei"/>
                         </a:rPr>
-                        <a:t>Ascend 测试设备（型号已脱敏）</a:t>
+                        <a:t>Ascend</a:t>
                       </a:r>
                       <a:r>
                         <a:rPr sz="1200" b="0">
@@ -19598,7 +19589,7 @@
                           <a:ea typeface="Microsoft YaHei"/>
                           <a:cs typeface="Microsoft YaHei"/>
                         </a:rPr>
-                        <a:t>TileLang（实验分支）</a:t>
+                        <a:t>TileLang</a:t>
                       </a:r>
                       <a:endParaRPr/>
                     </a:p>
@@ -20385,7 +20376,7 @@
           <p:nvPr/>
         </p:nvPicPr>
         <p:blipFill>
-          <a:blip xmlns:r="http://schemas.openxmlformats.org/officeDocument/2006/relationships" xmlns:a="http://schemas.openxmlformats.org/drawingml/2006/main" r:embed="R51c99032e80841af"/>
+          <a:blip xmlns:r="http://schemas.openxmlformats.org/officeDocument/2006/relationships" xmlns:a="http://schemas.openxmlformats.org/drawingml/2006/main" r:embed="Ra3d142c29c144eed"/>
           <a:stretch xmlns:a="http://schemas.openxmlformats.org/drawingml/2006/main"/>
         </p:blipFill>
         <p:spPr>
@@ -21375,7 +21366,7 @@
           <p:nvPr/>
         </p:nvPicPr>
         <p:blipFill>
-          <a:blip xmlns:r="http://schemas.openxmlformats.org/officeDocument/2006/relationships" xmlns:a="http://schemas.openxmlformats.org/drawingml/2006/main" r:embed="Re47fd9e7a06449cc"/>
+          <a:blip xmlns:r="http://schemas.openxmlformats.org/officeDocument/2006/relationships" xmlns:a="http://schemas.openxmlformats.org/drawingml/2006/main" r:embed="R93dbab7c905847c1"/>
           <a:stretch xmlns:a="http://schemas.openxmlformats.org/drawingml/2006/main"/>
         </p:blipFill>
         <p:spPr>
@@ -21397,7 +21388,7 @@
           <p:nvPr/>
         </p:nvPicPr>
         <p:blipFill>
-          <a:blip xmlns:r="http://schemas.openxmlformats.org/officeDocument/2006/relationships" xmlns:a="http://schemas.openxmlformats.org/drawingml/2006/main" r:embed="R5d324045b62b4b74"/>
+          <a:blip xmlns:r="http://schemas.openxmlformats.org/officeDocument/2006/relationships" xmlns:a="http://schemas.openxmlformats.org/drawingml/2006/main" r:embed="Red3765e108f241e0"/>
           <a:stretch xmlns:a="http://schemas.openxmlformats.org/drawingml/2006/main">
             <a:fillRect l="0" t="0" r="0" b="0"/>
           </a:stretch>
@@ -22811,7 +22802,7 @@
           <p:nvPr/>
         </p:nvPicPr>
         <p:blipFill>
-          <a:blip xmlns:r="http://schemas.openxmlformats.org/officeDocument/2006/relationships" xmlns:a="http://schemas.openxmlformats.org/drawingml/2006/main" r:embed="R557ad71f2a694063"/>
+          <a:blip xmlns:r="http://schemas.openxmlformats.org/officeDocument/2006/relationships" xmlns:a="http://schemas.openxmlformats.org/drawingml/2006/main" r:embed="Re59246f14693417a"/>
           <a:stretch xmlns:a="http://schemas.openxmlformats.org/drawingml/2006/main"/>
         </p:blipFill>
         <p:spPr>
@@ -23112,7 +23103,7 @@
           <p:nvPr/>
         </p:nvPicPr>
         <p:blipFill>
-          <a:blip xmlns:r="http://schemas.openxmlformats.org/officeDocument/2006/relationships" xmlns:a="http://schemas.openxmlformats.org/drawingml/2006/main" r:embed="R892ab8a6603e4372"/>
+          <a:blip xmlns:r="http://schemas.openxmlformats.org/officeDocument/2006/relationships" xmlns:a="http://schemas.openxmlformats.org/drawingml/2006/main" r:embed="R5e4f796f62fe49e4"/>
           <a:stretch xmlns:a="http://schemas.openxmlformats.org/drawingml/2006/main"/>
         </p:blipFill>
         <p:spPr>
@@ -24025,7 +24016,7 @@
           <p:nvPr/>
         </p:nvPicPr>
         <p:blipFill>
-          <a:blip xmlns:r="http://schemas.openxmlformats.org/officeDocument/2006/relationships" xmlns:a="http://schemas.openxmlformats.org/drawingml/2006/main" r:embed="R7bb0aba5092e40a0"/>
+          <a:blip xmlns:r="http://schemas.openxmlformats.org/officeDocument/2006/relationships" xmlns:a="http://schemas.openxmlformats.org/drawingml/2006/main" r:embed="R9ca69219ef22483d"/>
           <a:stretch xmlns:a="http://schemas.openxmlformats.org/drawingml/2006/main"/>
         </p:blipFill>
         <p:spPr>
@@ -25175,7 +25166,7 @@
           <p:nvPr/>
         </p:nvPicPr>
         <p:blipFill>
-          <a:blip xmlns:r="http://schemas.openxmlformats.org/officeDocument/2006/relationships" xmlns:a="http://schemas.openxmlformats.org/drawingml/2006/main" r:embed="R34baac5d3fb14819"/>
+          <a:blip xmlns:r="http://schemas.openxmlformats.org/officeDocument/2006/relationships" xmlns:a="http://schemas.openxmlformats.org/drawingml/2006/main" r:embed="Rec35f22928134288"/>
           <a:stretch xmlns:a="http://schemas.openxmlformats.org/drawingml/2006/main"/>
         </p:blipFill>
         <p:spPr>

</xml_diff>